<commit_message>
Availability: telemetry before capacity; drop warm-replica causal claim (#72)
Co-Authored-By: Claude Opus 5.5 (1M context) <noreply@anthropic.com>
</commit_message>
<xml_diff>
--- a/ebr/Northstar_EBR_Oct2026.pptx
+++ b/ebr/Northstar_EBR_Oct2026.pptx
@@ -113,21 +113,21 @@
   <p:extLst>
     <p:ext uri="{521415D9-36F7-43E2-AB2F-B90AF26B5E84}">
       <p14:sectionLst xmlns:p14="http://schemas.microsoft.com/office/powerpoint/2010/main">
-        <p14:section name="Results" id="{13af140a-ecca-0042-808a-63e8509fbf8e}">
+        <p14:section name="Results" id="{94b35f01-40dd-06fa-b70f-2b19c4551b67}">
           <p14:sldIdLst>
             <p14:sldId id="256"/>
             <p14:sldId id="257"/>
             <p14:sldId id="258"/>
           </p14:sldIdLst>
         </p14:section>
-        <p14:section name="Expansion" id="{358abec7-103f-5049-5779-517b3509f4dc}">
+        <p14:section name="Expansion" id="{2b3fcfbd-308e-abef-01fe-4664299a3d7b}">
           <p14:sldIdLst>
             <p14:sldId id="259"/>
             <p14:sldId id="260"/>
             <p14:sldId id="261"/>
           </p14:sldIdLst>
         </p14:section>
-        <p14:section name="Decision" id="{55953de3-5269-f434-78cc-a77187941218}">
+        <p14:section name="Decision" id="{eb3d59db-1b5b-ad09-0897-c7d45138365d}">
           <p14:sldIdLst>
             <p14:sldId id="262"/>
           </p14:sldIdLst>
@@ -1117,7 +1117,7 @@
           <a:p>
             <a:r>
               <a:rPr lang="en-US" dirty="0"/>
-              <a:t>Be direct about the trade-off. Atlas scales to zero when quiet, which is why the August bill is low and why the first requests after a lull can fail while capacity spins up. Holding capacity warm for Atlas alone would cost about $5.8k a month, $8.8k with EU-only placement, to gain roughly 22 minutes of availability a month. We don’t recommend that. For now: retune scale-up thresholds and pre-warm before planned promotions. The always-on floor and 99.9% arrive with the shared deployment, where five brands make it about $1.2k to $1.8k each.</a:t>
+              <a:t>Be precise about what we know. Availability averaged 99.85% and missed 99.9% on 27 of 31 days, 25 of them outside the two incidents, so this is not just the burst days. At 19,000 to 31,000 requests a day Atlas is unlikely to sit idle at zero for long, so we should not assume cold starts are the cause. The next step is the deployment telemetry: scale-up events and error codes by hour. Meanwhile we retune scale-up thresholds and pre-warm before planned promotions. Always-on capacity for Atlas alone would cost about $5.8k a month, $8.8k with EU-only placement; we would only recommend it if the telemetry shows scale-up is driving the misses. On the shared deployment the same capacity is about $1.2k to $1.8k per brand.</a:t>
             </a:r>
             <a:endParaRPr lang="en-US" dirty="0"/>
           </a:p>
@@ -1469,7 +1469,7 @@
           <a:p>
             <a:r>
               <a:rPr lang="en-US" dirty="0"/>
-              <a:t>Close on the one risk that matters: if group sponsorship doesn’t happen, the rollout stays with Atlas and the shared capacity never pays for itself, for Northstar or for the 99.9% target. Ask for three things: a named group sponsor, joint agreement on the Ridgeline criteria, and always-on capacity committed alongside a second brand rather than for Atlas alone. Then land the five messages.</a:t>
+              <a:t>Close on the one risk that matters: if group sponsorship doesn’t happen, the rollout stays with Atlas and the shared capacity never pays for itself. Ask for three things: a named group sponsor, joint agreement on the Ridgeline criteria, and shared capacity sized alongside a second brand, based on what the telemetry shows. Then land the five messages.</a:t>
             </a:r>
             <a:endParaRPr lang="en-US" dirty="0"/>
           </a:p>
@@ -3622,7 +3622,7 @@
                   <a:srgbClr val="5A5E63"/>
                 </a:solidFill>
               </a:rPr>
-              <a:t>Met on 4 of 31 days, all in the final week. The fix has a cost (next slide).</a:t>
+              <a:t>Met on 4 of 31 days, all in the final week. Cause under review (next slide).</a:t>
             </a:r>
             <a:endParaRPr lang="en-US" sz="1300" dirty="0"/>
           </a:p>
@@ -3865,7 +3865,7 @@
                   <a:schemeClr val="tx1"/>
                 </a:solidFill>
               </a:rPr>
-              <a:t>99.9% arrives with shared capacity, not a 5x bill</a:t>
+              <a:t>Find the cause before buying capacity</a:t>
             </a:r>
             <a:endParaRPr lang="en-US" sz="3400" dirty="0"/>
           </a:p>
@@ -3901,7 +3901,7 @@
                   <a:schemeClr val="tx1"/>
                 </a:solidFill>
               </a:rPr>
-              <a:t>Atlas scales its capacity down when traffic is quiet. That keeps the bill low, and it explains most of August’s availability misses: after a quiet spell, the first requests wait while capacity comes back up.</a:t>
+              <a:t>Availability averaged 99.85% and fell short of 99.9% on 27 of 31 days, not only on the two incident days. Daily metrics can’t show why, so we diagnose from deployment telemetry before changing capacity.</a:t>
             </a:r>
             <a:endParaRPr lang="en-US" sz="1500" dirty="0"/>
           </a:p>
@@ -4025,7 +4025,7 @@
                   <a:schemeClr val="tx1"/>
                 </a:solidFill>
               </a:rPr>
-              <a:t>Tune what Atlas has</a:t>
+              <a:t>Diagnose and tune</a:t>
             </a:r>
             <a:endParaRPr lang="en-US" sz="1800" dirty="0"/>
           </a:p>
@@ -4065,7 +4065,7 @@
                   <a:schemeClr val="tx1"/>
                 </a:solidFill>
               </a:rPr>
-              <a:t>Retune scale-up thresholds</a:t>
+              <a:t>Review deployment telemetry together</a:t>
             </a:r>
             <a:endParaRPr lang="en-US" sz="1400" dirty="0"/>
           </a:p>
@@ -4083,7 +4083,7 @@
                   <a:schemeClr val="tx1"/>
                 </a:solidFill>
               </a:rPr>
-              <a:t>Pre-warm capacity before planned promotions</a:t>
+              <a:t>Retune scale-up; pre-warm before promotions</a:t>
             </a:r>
             <a:endParaRPr lang="en-US" sz="1400" dirty="0"/>
           </a:p>
@@ -4119,7 +4119,7 @@
                   <a:srgbClr val="5A5E63"/>
                 </a:solidFill>
               </a:rPr>
-              <a:t>Bill stays ~$1.4k/month at current traffic; availability ~99.85%</a:t>
+              <a:t>Bill stays ~$1.4k/month at current traffic</a:t>
             </a:r>
             <a:endParaRPr lang="en-US" sz="1300" dirty="0"/>
           </a:p>
@@ -4207,7 +4207,7 @@
                   <a:srgbClr val="F14539"/>
                 </a:solidFill>
               </a:rPr>
-              <a:t>NOT RECOMMENDED</a:t>
+              <a:t>ONLY IF THE DATA SHOWS IT</a:t>
             </a:r>
             <a:endParaRPr lang="en-US" sz="1100" dirty="0"/>
           </a:p>
@@ -4337,7 +4337,7 @@
                   <a:srgbClr val="5A5E63"/>
                 </a:solidFill>
               </a:rPr>
-              <a:t>Buys about 22 minutes a month of extra availability</a:t>
+              <a:t>Justified only if scale-up is driving the misses</a:t>
             </a:r>
             <a:endParaRPr lang="en-US" sz="1300" dirty="0"/>
           </a:p>
@@ -4555,7 +4555,7 @@
                   <a:srgbClr val="5A5E63"/>
                 </a:solidFill>
               </a:rPr>
-              <a:t>This is where 99.9% becomes efficient</a:t>
+              <a:t>Baseline capacity is affordable once shared</a:t>
             </a:r>
             <a:endParaRPr lang="en-US" sz="1300" dirty="0"/>
           </a:p>
@@ -9094,7 +9094,7 @@
                   <a:schemeClr val="bg1"/>
                 </a:solidFill>
               </a:rPr>
-              <a:t>Without group-level sponsorship the rollout stays with Atlas, and shared capacity never carries enough volume to make 99.9% and per-brand cost efficient.</a:t>
+              <a:t>Without group-level sponsorship the rollout stays with Atlas, and shared capacity never carries enough volume to make per-brand cost efficient.</a:t>
             </a:r>
             <a:endParaRPr lang="en-US" sz="1600" dirty="0"/>
           </a:p>
@@ -9206,7 +9206,7 @@
                   <a:schemeClr val="bg1"/>
                 </a:solidFill>
               </a:rPr>
-              <a:t>Commit always-on capacity alongside a second brand</a:t>
+              <a:t>Size shared capacity alongside a second brand</a:t>
             </a:r>
             <a:endParaRPr lang="en-US" sz="1400" dirty="0"/>
           </a:p>
@@ -9458,7 +9458,7 @@
                   <a:schemeClr val="bg1"/>
                 </a:solidFill>
               </a:rPr>
-              <a:t>99.85% is what Atlas alone buys today; 99.9% comes with shared capacity.</a:t>
+              <a:t>99.85% today: we find the cause in telemetry before buying capacity.</a:t>
             </a:r>
             <a:endParaRPr lang="en-US" sz="1400" dirty="0"/>
           </a:p>

</xml_diff>

<commit_message>
Adapters learn tone, workflow and policy-following behaviour; policy facts stay in RAG (#77)
Co-Authored-By: Claude Opus 5.5 (1M context) <noreply@anthropic.com>
</commit_message>
<xml_diff>
--- a/ebr/Northstar_EBR_Oct2026.pptx
+++ b/ebr/Northstar_EBR_Oct2026.pptx
@@ -113,21 +113,21 @@
   <p:extLst>
     <p:ext uri="{521415D9-36F7-43E2-AB2F-B90AF26B5E84}">
       <p14:sectionLst xmlns:p14="http://schemas.microsoft.com/office/powerpoint/2010/main">
-        <p14:section name="Results" id="{94b35f01-40dd-06fa-b70f-2b19c4551b67}">
+        <p14:section name="Results" id="{957c0f9f-06bf-9ff4-cdc8-91f3ebe4b906}">
           <p14:sldIdLst>
             <p14:sldId id="256"/>
             <p14:sldId id="257"/>
             <p14:sldId id="258"/>
           </p14:sldIdLst>
         </p14:section>
-        <p14:section name="Expansion" id="{2b3fcfbd-308e-abef-01fe-4664299a3d7b}">
+        <p14:section name="Expansion" id="{a67ec4d8-8943-2190-bf69-5ce77bef326a}">
           <p14:sldIdLst>
             <p14:sldId id="259"/>
             <p14:sldId id="260"/>
             <p14:sldId id="261"/>
           </p14:sldIdLst>
         </p14:section>
-        <p14:section name="Decision" id="{eb3d59db-1b5b-ad09-0897-c7d45138365d}">
+        <p14:section name="Decision" id="{281eb9c4-e50f-1c67-56fa-6704c5c6a0d2}">
           <p14:sldIdLst>
             <p14:sldId id="262"/>
           </p14:sldIdLst>
@@ -1205,7 +1205,7 @@
           <a:p>
             <a:r>
               <a:rPr lang="en-US" dirty="0"/>
-              <a:t>The architecture: one open-weight base model on a shared deployment, one adapter per brand for tone and policy, and a separate knowledge index and system prompt per brand. Atlas’s adapter moves over unchanged. Data isolation sits where it matters, in each brand’s index and adapter. Halden, the largest brand, can move to its own deployment once its volume keeps capacity busy. Why not reuse Atlas with a new prompt: its tone and return policies are learned and would leak. Why not five separate models: five deployments to run and retrain, and the smaller brands don’t have enough transcripts.</a:t>
+              <a:t>The architecture: one open-weight base model on a shared deployment, one adapter per brand for tone, workflow and policy-following behaviour, and a separate knowledge index and system prompt per brand. Policy facts such as return windows live in the index, not the weights, so they can change without retraining. Atlas’s adapter moves over unchanged. Data isolation sits where it matters, in each brand’s index and adapter. Halden, the largest brand, can move to its own deployment once its volume keeps capacity busy. Why not reuse Atlas with a new prompt: its tone and policy-handling habits are learned and would leak. Why not five separate models: five deployments to run and retrain, and the smaller brands don’t have enough transcripts.</a:t>
             </a:r>
             <a:endParaRPr lang="en-US" dirty="0"/>
           </a:p>
@@ -6445,7 +6445,7 @@
                   <a:srgbClr val="5A5E63"/>
                 </a:solidFill>
               </a:rPr>
-              <a:t>Atlas’s tone and return policies are learned into its adapter and would leak into other brands.</a:t>
+              <a:t>Atlas’s tone and policy-handling habits are learned into its adapter and would leak into other brands.</a:t>
             </a:r>
             <a:endParaRPr lang="en-US" sz="1400" dirty="0"/>
           </a:p>
@@ -6708,7 +6708,7 @@
                   <a:schemeClr val="tx1"/>
                 </a:solidFill>
               </a:rPr>
-              <a:t>Ridgeline is closest to Atlas in product and customer, uses the same Zendesk tooling and runs at moderate volume, so it tests tone and return-policy transfer with limited exposure.</a:t>
+              <a:t>Ridgeline is closest to Atlas in product and customer, uses the same Zendesk tooling and runs at moderate volume, so it tests tone and return-policy handling with limited exposure.</a:t>
             </a:r>
             <a:endParaRPr lang="en-US" sz="1500" dirty="0"/>
           </a:p>
@@ -6996,7 +6996,7 @@
                   <a:srgbClr val="5A5E63"/>
                 </a:solidFill>
               </a:rPr>
-              <a:t>Tone and policy learned from Ridgeline transcripts.</a:t>
+              <a:t>Tone and policy-following learned from Ridgeline transcripts.</a:t>
             </a:r>
             <a:endParaRPr lang="en-US" sz="1400" dirty="0"/>
           </a:p>

</xml_diff>

<commit_message>
EBR: key messages on the cover; slide 9 focuses on the biggest risk (#82)
Co-Authored-By: Claude Opus 5.5 (1M context) <noreply@anthropic.com>
</commit_message>
<xml_diff>
--- a/ebr/Northstar_EBR_Oct2026.pptx
+++ b/ebr/Northstar_EBR_Oct2026.pptx
@@ -134,12 +134,12 @@
   <p:extLst>
     <p:ext uri="{521415D9-36F7-43E2-AB2F-B90AF26B5E84}">
       <p14:sectionLst xmlns:p14="http://schemas.microsoft.com/office/powerpoint/2010/main">
-        <p14:section name="Opening" id="{544AF27C-6BDC-E6B5-CAAD-E879D4E0EF83}">
+        <p14:section name="Opening" id="{C97E9E27-640B-AF24-2EBC-A93587E0356A}">
           <p14:sldIdLst>
             <p14:sldId id="256"/>
           </p14:sldIdLst>
         </p14:section>
-        <p14:section name="Results" id="{BBDE147B-622E-4C0F-93DE-F54F205D475D}">
+        <p14:section name="Results" id="{9F2EF559-D229-BEFA-892A-FA3588F5D4B9}">
           <p14:sldIdLst>
             <p14:sldId id="257"/>
             <p14:sldId id="258"/>
@@ -147,19 +147,19 @@
             <p14:sldId id="260"/>
           </p14:sldIdLst>
         </p14:section>
-        <p14:section name="Expansion" id="{0CBF0593-71F3-64AE-0D62-1EE179539EFD}">
+        <p14:section name="Expansion" id="{096516F7-8E5E-7054-E8EB-DE872B8D2EB8}">
           <p14:sldIdLst>
             <p14:sldId id="261"/>
             <p14:sldId id="262"/>
             <p14:sldId id="263"/>
           </p14:sldIdLst>
         </p14:section>
-        <p14:section name="Decision" id="{F3CB7C93-0F50-24A7-56B7-F2A6B3E87E3C}">
+        <p14:section name="Decision" id="{94B122C4-F1D7-530E-E4BC-549E8A23CA5F}">
           <p14:sldIdLst>
             <p14:sldId id="264"/>
           </p14:sldIdLst>
         </p14:section>
-        <p14:section name="Close" id="{9D0AA227-3B72-A991-CD18-CFFA796E0B8C}">
+        <p14:section name="Close" id="{3ABBE099-792F-CC90-4015-720A2DB27EAD}">
           <p14:sldIdLst>
             <p14:sldId id="265"/>
           </p14:sldIdLst>
@@ -351,7 +351,7 @@
           <c:smooth val="1"/>
           <c:extLst>
             <c:ext xmlns:c16="http://schemas.microsoft.com/office/drawing/2014/chart" uri="{C3380CC4-5D6E-409C-BE32-E72D297353CC}">
-              <c16:uniqueId val="{00000000-FEF2-4954-A073-E8C5FFF4107F}"/>
+              <c16:uniqueId val="{00000000-2583-4CDB-A3B0-57D81481A681}"/>
             </c:ext>
           </c:extLst>
         </c:ser>
@@ -510,7 +510,7 @@
           <c:smooth val="1"/>
           <c:extLst>
             <c:ext xmlns:c16="http://schemas.microsoft.com/office/drawing/2014/chart" uri="{C3380CC4-5D6E-409C-BE32-E72D297353CC}">
-              <c16:uniqueId val="{00000001-FEF2-4954-A073-E8C5FFF4107F}"/>
+              <c16:uniqueId val="{00000001-2583-4CDB-A3B0-57D81481A681}"/>
             </c:ext>
           </c:extLst>
         </c:ser>
@@ -822,7 +822,7 @@
           <c:smooth val="1"/>
           <c:extLst>
             <c:ext xmlns:c16="http://schemas.microsoft.com/office/drawing/2014/chart" uri="{C3380CC4-5D6E-409C-BE32-E72D297353CC}">
-              <c16:uniqueId val="{00000000-8D75-4949-BB7E-62189FF17DA3}"/>
+              <c16:uniqueId val="{00000000-BF6E-4619-824B-CCC8747C5D83}"/>
             </c:ext>
           </c:extLst>
         </c:ser>
@@ -981,7 +981,7 @@
           <c:smooth val="1"/>
           <c:extLst>
             <c:ext xmlns:c16="http://schemas.microsoft.com/office/drawing/2014/chart" uri="{C3380CC4-5D6E-409C-BE32-E72D297353CC}">
-              <c16:uniqueId val="{00000001-8D75-4949-BB7E-62189FF17DA3}"/>
+              <c16:uniqueId val="{00000001-BF6E-4619-824B-CCC8747C5D83}"/>
             </c:ext>
           </c:extLst>
         </c:ser>
@@ -1293,7 +1293,7 @@
           <c:smooth val="1"/>
           <c:extLst>
             <c:ext xmlns:c16="http://schemas.microsoft.com/office/drawing/2014/chart" uri="{C3380CC4-5D6E-409C-BE32-E72D297353CC}">
-              <c16:uniqueId val="{00000000-0F9E-40B3-8C11-9C790402B42F}"/>
+              <c16:uniqueId val="{00000000-5DEA-43FB-801C-1D68EBEB771A}"/>
             </c:ext>
           </c:extLst>
         </c:ser>
@@ -1452,7 +1452,7 @@
           <c:smooth val="1"/>
           <c:extLst>
             <c:ext xmlns:c16="http://schemas.microsoft.com/office/drawing/2014/chart" uri="{C3380CC4-5D6E-409C-BE32-E72D297353CC}">
-              <c16:uniqueId val="{00000001-0F9E-40B3-8C11-9C790402B42F}"/>
+              <c16:uniqueId val="{00000001-5DEA-43FB-801C-1D68EBEB771A}"/>
             </c:ext>
           </c:extLst>
         </c:ser>
@@ -1611,7 +1611,7 @@
     </p:spTree>
     <p:extLst>
       <p:ext uri="{BB962C8B-B14F-4D97-AF65-F5344CB8AC3E}">
-        <p14:creationId xmlns:p14="http://schemas.microsoft.com/office/powerpoint/2010/main" val="2408404908"/>
+        <p14:creationId xmlns:p14="http://schemas.microsoft.com/office/powerpoint/2010/main" val="3363676601"/>
       </p:ext>
     </p:extLst>
   </p:cSld>
@@ -1757,7 +1757,7 @@
           <a:p>
             <a:r>
               <a:rPr lang="en-US" dirty="0"/>
-              <a:t>Welcome and purpose. This review covers Atlas’s first month in production, measured on the same data and the same scoring as the dashboard Northstar already has, and the proposal to bring the four sister brands onto the platform. We want to leave today with a group sponsor and agreement on the Ridgeline pilot.</a:t>
+              <a:t>Welcome and purpose. This review covers Atlas’s first month in production, measured on the same data and the same scoring as the dashboard Northstar already has, and the proposal to bring the four sister brands onto the platform. The five key messages are the whole story in one place; everything that follows is the evidence. One: month one delivered, with automation at 70.1% in the final week and faster, better-rated answers. Two: quality improved every week. Three: availability is 99.85%, and we will find the cause in telemetry before anyone buys capacity. Four: one base model with one adapter per brand keeps each brand’s voice and data separate. Five: we are asking for a group sponsor today and Ridgeline as the pilot.</a:t>
             </a:r>
           </a:p>
         </p:txBody>
@@ -2540,7 +2540,7 @@
           <a:p>
             <a:r>
               <a:rPr lang="en-US" dirty="0"/>
-              <a:t>Close on the one risk that matters: if group sponsorship doesn’t happen, the rollout stays with Atlas and the shared capacity never pays for itself. Ask for three things: a named group sponsor, joint agreement on the Ridgeline criteria, and shared capacity sized alongside a second brand, based on what the telemetry shows. Then land the five messages.</a:t>
+              <a:t>Close on the one risk that matters. The platform worked in month one; the risk is that nobody above brand level owns the rollout, so it stays with Atlas. If that happens, always-on capacity stays a single-brand cost, the sister brands, which carry most of the Tier-1 volume, don’t get the gains, and each brand makes its own tooling decision. The mitigation is three concrete asks: a named group sponsor at this review, the Ridgeline criteria agreed together, and shared capacity sized alongside a second brand from a load benchmark, never for Atlas alone.</a:t>
             </a:r>
           </a:p>
         </p:txBody>
@@ -3622,314 +3622,14 @@
       </p:pic>
       <p:sp>
         <p:nvSpPr>
-          <p:cNvPr id="3" name="Shape 0"/>
-          <p:cNvSpPr/>
-          <p:nvPr/>
-        </p:nvSpPr>
-        <p:spPr>
-          <a:xfrm>
-            <a:off x="10957255" y="841248"/>
-            <a:ext cx="219456" cy="219456"/>
-          </a:xfrm>
-          <a:prstGeom prst="rect">
-            <a:avLst/>
-          </a:prstGeom>
-          <a:solidFill>
-            <a:srgbClr val="6720FF"/>
-          </a:solidFill>
-          <a:ln/>
-        </p:spPr>
-      </p:sp>
-      <p:sp>
-        <p:nvSpPr>
-          <p:cNvPr id="4" name="Shape 1"/>
-          <p:cNvSpPr/>
-          <p:nvPr/>
-        </p:nvSpPr>
-        <p:spPr>
-          <a:xfrm>
-            <a:off x="11240719" y="841248"/>
-            <a:ext cx="219456" cy="219456"/>
-          </a:xfrm>
-          <a:prstGeom prst="rect">
-            <a:avLst/>
-          </a:prstGeom>
-          <a:solidFill>
-            <a:srgbClr val="6720FF"/>
-          </a:solidFill>
-          <a:ln/>
-        </p:spPr>
-      </p:sp>
-      <p:sp>
-        <p:nvSpPr>
-          <p:cNvPr id="5" name="Shape 2"/>
-          <p:cNvSpPr/>
-          <p:nvPr/>
-        </p:nvSpPr>
-        <p:spPr>
-          <a:xfrm>
-            <a:off x="10673791" y="1124712"/>
-            <a:ext cx="219456" cy="219456"/>
-          </a:xfrm>
-          <a:prstGeom prst="rect">
-            <a:avLst/>
-          </a:prstGeom>
-          <a:solidFill>
-            <a:srgbClr val="6720FF"/>
-          </a:solidFill>
-          <a:ln/>
-        </p:spPr>
-      </p:sp>
-      <p:sp>
-        <p:nvSpPr>
-          <p:cNvPr id="6" name="Shape 3"/>
-          <p:cNvSpPr/>
-          <p:nvPr/>
-        </p:nvSpPr>
-        <p:spPr>
-          <a:xfrm>
-            <a:off x="10957255" y="1124712"/>
-            <a:ext cx="219456" cy="219456"/>
-          </a:xfrm>
-          <a:prstGeom prst="rect">
-            <a:avLst/>
-          </a:prstGeom>
-          <a:solidFill>
-            <a:srgbClr val="CEB4FF"/>
-          </a:solidFill>
-          <a:ln/>
-        </p:spPr>
-      </p:sp>
-      <p:sp>
-        <p:nvSpPr>
-          <p:cNvPr id="7" name="Shape 4"/>
-          <p:cNvSpPr/>
-          <p:nvPr/>
-        </p:nvSpPr>
-        <p:spPr>
-          <a:xfrm>
-            <a:off x="11240719" y="1124712"/>
-            <a:ext cx="219456" cy="219456"/>
-          </a:xfrm>
-          <a:prstGeom prst="rect">
-            <a:avLst/>
-          </a:prstGeom>
-          <a:solidFill>
-            <a:srgbClr val="6720FF"/>
-          </a:solidFill>
-          <a:ln/>
-        </p:spPr>
-      </p:sp>
-      <p:sp>
-        <p:nvSpPr>
-          <p:cNvPr id="8" name="Shape 5"/>
-          <p:cNvSpPr/>
-          <p:nvPr/>
-        </p:nvSpPr>
-        <p:spPr>
-          <a:xfrm>
-            <a:off x="10390327" y="1408176"/>
-            <a:ext cx="219456" cy="219456"/>
-          </a:xfrm>
-          <a:prstGeom prst="rect">
-            <a:avLst/>
-          </a:prstGeom>
-          <a:solidFill>
-            <a:srgbClr val="6720FF"/>
-          </a:solidFill>
-          <a:ln/>
-        </p:spPr>
-      </p:sp>
-      <p:sp>
-        <p:nvSpPr>
-          <p:cNvPr id="9" name="Shape 6"/>
-          <p:cNvSpPr/>
-          <p:nvPr/>
-        </p:nvSpPr>
-        <p:spPr>
-          <a:xfrm>
-            <a:off x="10673791" y="1408176"/>
-            <a:ext cx="219456" cy="219456"/>
-          </a:xfrm>
-          <a:prstGeom prst="rect">
-            <a:avLst/>
-          </a:prstGeom>
-          <a:solidFill>
-            <a:srgbClr val="CEB4FF"/>
-          </a:solidFill>
-          <a:ln/>
-        </p:spPr>
-      </p:sp>
-      <p:sp>
-        <p:nvSpPr>
-          <p:cNvPr id="10" name="Shape 7"/>
-          <p:cNvSpPr/>
-          <p:nvPr/>
-        </p:nvSpPr>
-        <p:spPr>
-          <a:xfrm>
-            <a:off x="10957255" y="1408176"/>
-            <a:ext cx="219456" cy="219456"/>
-          </a:xfrm>
-          <a:prstGeom prst="rect">
-            <a:avLst/>
-          </a:prstGeom>
-          <a:solidFill>
-            <a:srgbClr val="E0D2FD"/>
-          </a:solidFill>
-          <a:ln/>
-        </p:spPr>
-      </p:sp>
-      <p:sp>
-        <p:nvSpPr>
-          <p:cNvPr id="11" name="Shape 8"/>
-          <p:cNvSpPr/>
-          <p:nvPr/>
-        </p:nvSpPr>
-        <p:spPr>
-          <a:xfrm>
-            <a:off x="11240719" y="1408176"/>
-            <a:ext cx="219456" cy="219456"/>
-          </a:xfrm>
-          <a:prstGeom prst="rect">
-            <a:avLst/>
-          </a:prstGeom>
-          <a:solidFill>
-            <a:srgbClr val="CEB4FF"/>
-          </a:solidFill>
-          <a:ln/>
-        </p:spPr>
-      </p:sp>
-      <p:sp>
-        <p:nvSpPr>
-          <p:cNvPr id="12" name="Shape 9"/>
-          <p:cNvSpPr/>
-          <p:nvPr/>
-        </p:nvSpPr>
-        <p:spPr>
-          <a:xfrm>
-            <a:off x="10106863" y="1691640"/>
-            <a:ext cx="219456" cy="219456"/>
-          </a:xfrm>
-          <a:prstGeom prst="rect">
-            <a:avLst/>
-          </a:prstGeom>
-          <a:solidFill>
-            <a:srgbClr val="6720FF"/>
-          </a:solidFill>
-          <a:ln/>
-        </p:spPr>
-      </p:sp>
-      <p:sp>
-        <p:nvSpPr>
-          <p:cNvPr id="13" name="Shape 10"/>
-          <p:cNvSpPr/>
-          <p:nvPr/>
-        </p:nvSpPr>
-        <p:spPr>
-          <a:xfrm>
-            <a:off x="10390327" y="1691640"/>
-            <a:ext cx="219456" cy="219456"/>
-          </a:xfrm>
-          <a:prstGeom prst="rect">
-            <a:avLst/>
-          </a:prstGeom>
-          <a:solidFill>
-            <a:srgbClr val="CEB4FF"/>
-          </a:solidFill>
-          <a:ln/>
-        </p:spPr>
-      </p:sp>
-      <p:sp>
-        <p:nvSpPr>
-          <p:cNvPr id="14" name="Shape 11"/>
-          <p:cNvSpPr/>
-          <p:nvPr/>
-        </p:nvSpPr>
-        <p:spPr>
-          <a:xfrm>
-            <a:off x="10673791" y="1691640"/>
-            <a:ext cx="219456" cy="219456"/>
-          </a:xfrm>
-          <a:prstGeom prst="rect">
-            <a:avLst/>
-          </a:prstGeom>
-          <a:solidFill>
-            <a:srgbClr val="E0D2FD"/>
-          </a:solidFill>
-          <a:ln/>
-        </p:spPr>
-      </p:sp>
-      <p:sp>
-        <p:nvSpPr>
-          <p:cNvPr id="15" name="Shape 12"/>
-          <p:cNvSpPr/>
-          <p:nvPr/>
-        </p:nvSpPr>
-        <p:spPr>
-          <a:xfrm>
-            <a:off x="9823399" y="1975104"/>
-            <a:ext cx="219456" cy="219456"/>
-          </a:xfrm>
-          <a:prstGeom prst="rect">
-            <a:avLst/>
-          </a:prstGeom>
-          <a:solidFill>
-            <a:srgbClr val="6720FF"/>
-          </a:solidFill>
-          <a:ln/>
-        </p:spPr>
-      </p:sp>
-      <p:sp>
-        <p:nvSpPr>
-          <p:cNvPr id="16" name="Shape 13"/>
-          <p:cNvSpPr/>
-          <p:nvPr/>
-        </p:nvSpPr>
-        <p:spPr>
-          <a:xfrm>
-            <a:off x="10106863" y="1975104"/>
-            <a:ext cx="219456" cy="219456"/>
-          </a:xfrm>
-          <a:prstGeom prst="rect">
-            <a:avLst/>
-          </a:prstGeom>
-          <a:solidFill>
-            <a:srgbClr val="CEB4FF"/>
-          </a:solidFill>
-          <a:ln/>
-        </p:spPr>
-      </p:sp>
-      <p:sp>
-        <p:nvSpPr>
-          <p:cNvPr id="17" name="Shape 14"/>
-          <p:cNvSpPr/>
-          <p:nvPr/>
-        </p:nvSpPr>
-        <p:spPr>
-          <a:xfrm>
-            <a:off x="10390327" y="1975104"/>
-            <a:ext cx="219456" cy="219456"/>
-          </a:xfrm>
-          <a:prstGeom prst="rect">
-            <a:avLst/>
-          </a:prstGeom>
-          <a:solidFill>
-            <a:srgbClr val="E0D2FD"/>
-          </a:solidFill>
-          <a:ln/>
-        </p:spPr>
-      </p:sp>
-      <p:sp>
-        <p:nvSpPr>
-          <p:cNvPr id="18" name="Text 15"/>
-          <p:cNvSpPr txBox="1"/>
-          <p:nvPr/>
-        </p:nvSpPr>
-        <p:spPr>
-          <a:xfrm>
-            <a:off x="731520" y="2697480"/>
-            <a:ext cx="5486400" cy="274320"/>
+          <p:cNvPr id="3" name="Text 0"/>
+          <p:cNvSpPr txBox="1"/>
+          <p:nvPr/>
+        </p:nvSpPr>
+        <p:spPr>
+          <a:xfrm>
+            <a:off x="731520" y="2331720"/>
+            <a:ext cx="5394960" cy="274320"/>
           </a:xfrm>
           <a:prstGeom prst="rect">
             <a:avLst/>
@@ -3961,14 +3661,14 @@
       </p:sp>
       <p:sp>
         <p:nvSpPr>
-          <p:cNvPr id="19" name="Text 16"/>
-          <p:cNvSpPr txBox="1"/>
-          <p:nvPr/>
-        </p:nvSpPr>
-        <p:spPr>
-          <a:xfrm>
-            <a:off x="731520" y="3017520"/>
-            <a:ext cx="10728655" cy="914400"/>
+          <p:cNvPr id="4" name="Text 1"/>
+          <p:cNvSpPr txBox="1"/>
+          <p:nvPr/>
+        </p:nvSpPr>
+        <p:spPr>
+          <a:xfrm>
+            <a:off x="731520" y="2670048"/>
+            <a:ext cx="5394960" cy="1325880"/>
           </a:xfrm>
           <a:prstGeom prst="rect">
             <a:avLst/>
@@ -3981,10 +3681,13 @@
           <a:lstStyle/>
           <a:p>
             <a:pPr marL="0" indent="0">
-              <a:buNone/>
-            </a:pPr>
-            <a:r>
-              <a:rPr lang="en-US" sz="5000" kern="0" spc="-200" dirty="0">
+              <a:lnSpc>
+                <a:spcPct val="95000"/>
+              </a:lnSpc>
+              <a:buNone/>
+            </a:pPr>
+            <a:r>
+              <a:rPr lang="en-US" sz="4000" kern="0" spc="-160" dirty="0">
                 <a:solidFill>
                   <a:srgbClr val="16181D"/>
                 </a:solidFill>
@@ -3992,22 +3695,42 @@
                 <a:ea typeface="Inter Medium" pitchFamily="34" charset="-122"/>
                 <a:cs typeface="Inter Medium" pitchFamily="34" charset="-120"/>
               </a:rPr>
-              <a:t>Northstar Retail Group — Atlas</a:t>
-            </a:r>
-            <a:endParaRPr lang="en-US" sz="5000" dirty="0"/>
-          </a:p>
-        </p:txBody>
-      </p:sp>
-      <p:sp>
-        <p:nvSpPr>
-          <p:cNvPr id="20" name="Text 17"/>
-          <p:cNvSpPr txBox="1"/>
-          <p:nvPr/>
-        </p:nvSpPr>
-        <p:spPr>
-          <a:xfrm>
-            <a:off x="731520" y="4005072"/>
-            <a:ext cx="10728655" cy="457200"/>
+              <a:t>Northstar Retail Group</a:t>
+            </a:r>
+            <a:endParaRPr lang="en-US" sz="4000" dirty="0"/>
+          </a:p>
+          <a:p>
+            <a:pPr marL="0" indent="0">
+              <a:lnSpc>
+                <a:spcPct val="95000"/>
+              </a:lnSpc>
+              <a:buNone/>
+            </a:pPr>
+            <a:r>
+              <a:rPr lang="en-US" sz="4000" kern="0" spc="-160" dirty="0">
+                <a:solidFill>
+                  <a:srgbClr val="16181D"/>
+                </a:solidFill>
+                <a:latin typeface="Inter Medium" pitchFamily="34" charset="0"/>
+                <a:ea typeface="Inter Medium" pitchFamily="34" charset="-122"/>
+                <a:cs typeface="Inter Medium" pitchFamily="34" charset="-120"/>
+              </a:rPr>
+              <a:t>— Atlas</a:t>
+            </a:r>
+            <a:endParaRPr lang="en-US" sz="4000" dirty="0"/>
+          </a:p>
+        </p:txBody>
+      </p:sp>
+      <p:sp>
+        <p:nvSpPr>
+          <p:cNvPr id="5" name="Text 2"/>
+          <p:cNvSpPr txBox="1"/>
+          <p:nvPr/>
+        </p:nvSpPr>
+        <p:spPr>
+          <a:xfrm>
+            <a:off x="731520" y="4114800"/>
+            <a:ext cx="5029200" cy="731520"/>
           </a:xfrm>
           <a:prstGeom prst="rect">
             <a:avLst/>
@@ -4023,7 +3746,7 @@
               <a:buNone/>
             </a:pPr>
             <a:r>
-              <a:rPr lang="en-US" sz="2000" dirty="0">
+              <a:rPr lang="en-US" sz="1800" dirty="0">
                 <a:solidFill>
                   <a:srgbClr val="5A5E63"/>
                 </a:solidFill>
@@ -4033,25 +3756,29 @@
               </a:rPr>
               <a:t>Month one in production, and the plan for four more brands</a:t>
             </a:r>
-            <a:endParaRPr lang="en-US" sz="2000" dirty="0"/>
-          </a:p>
-        </p:txBody>
-      </p:sp>
-      <p:sp>
-        <p:nvSpPr>
-          <p:cNvPr id="21" name="Shape 18"/>
-          <p:cNvSpPr/>
-          <p:nvPr/>
-        </p:nvSpPr>
-        <p:spPr>
-          <a:xfrm>
-            <a:off x="731520" y="5760720"/>
-            <a:ext cx="10728655" cy="0"/>
-          </a:xfrm>
-          <a:prstGeom prst="line">
-            <a:avLst/>
-          </a:prstGeom>
-          <a:noFill/>
+            <a:endParaRPr lang="en-US" sz="1800" dirty="0"/>
+          </a:p>
+        </p:txBody>
+      </p:sp>
+      <p:sp>
+        <p:nvSpPr>
+          <p:cNvPr id="6" name="key-messages"/>
+          <p:cNvSpPr/>
+          <p:nvPr/>
+        </p:nvSpPr>
+        <p:spPr>
+          <a:xfrm>
+            <a:off x="6537960" y="841248"/>
+            <a:ext cx="4922215" cy="4645152"/>
+          </a:xfrm>
+          <a:prstGeom prst="roundRect">
+            <a:avLst>
+              <a:gd name="adj" fmla="val 2362"/>
+            </a:avLst>
+          </a:prstGeom>
+          <a:solidFill>
+            <a:srgbClr val="FAF7FF"/>
+          </a:solidFill>
           <a:ln w="9525">
             <a:solidFill>
               <a:srgbClr val="E6EAF4"/>
@@ -4062,14 +3789,14 @@
       </p:sp>
       <p:sp>
         <p:nvSpPr>
-          <p:cNvPr id="22" name="Text 19"/>
-          <p:cNvSpPr txBox="1"/>
-          <p:nvPr/>
-        </p:nvSpPr>
-        <p:spPr>
-          <a:xfrm>
-            <a:off x="731520" y="5925312"/>
-            <a:ext cx="5486400" cy="274320"/>
+          <p:cNvPr id="7" name="Text 4"/>
+          <p:cNvSpPr txBox="1"/>
+          <p:nvPr/>
+        </p:nvSpPr>
+        <p:spPr>
+          <a:xfrm>
+            <a:off x="6812280" y="1115568"/>
+            <a:ext cx="2743200" cy="219456"/>
           </a:xfrm>
           <a:prstGeom prst="rect">
             <a:avLst/>
@@ -4087,12 +3814,461 @@
             <a:r>
               <a:rPr lang="en-US" sz="1100" dirty="0">
                 <a:solidFill>
-                  <a:srgbClr val="5A5E63"/>
+                  <a:srgbClr val="501BC4"/>
+                </a:solidFill>
+                <a:latin typeface="Inter Medium" pitchFamily="34" charset="0"/>
+                <a:ea typeface="Inter Medium" pitchFamily="34" charset="-122"/>
+                <a:cs typeface="Inter Medium" pitchFamily="34" charset="-120"/>
+              </a:rPr>
+              <a:t>Key messages</a:t>
+            </a:r>
+            <a:endParaRPr lang="en-US" sz="1100" dirty="0"/>
+          </a:p>
+        </p:txBody>
+      </p:sp>
+      <p:sp>
+        <p:nvSpPr>
+          <p:cNvPr id="8" name="Shape 5"/>
+          <p:cNvSpPr/>
+          <p:nvPr/>
+        </p:nvSpPr>
+        <p:spPr>
+          <a:xfrm>
+            <a:off x="6830568" y="1781251"/>
+            <a:ext cx="118872" cy="118872"/>
+          </a:xfrm>
+          <a:prstGeom prst="rect">
+            <a:avLst/>
+          </a:prstGeom>
+          <a:solidFill>
+            <a:srgbClr val="6720FF"/>
+          </a:solidFill>
+          <a:ln/>
+        </p:spPr>
+      </p:sp>
+      <p:sp>
+        <p:nvSpPr>
+          <p:cNvPr id="9" name="Text 6"/>
+          <p:cNvSpPr txBox="1"/>
+          <p:nvPr/>
+        </p:nvSpPr>
+        <p:spPr>
+          <a:xfrm>
+            <a:off x="7141464" y="1444752"/>
+            <a:ext cx="4044391" cy="791870"/>
+          </a:xfrm>
+          <a:prstGeom prst="rect">
+            <a:avLst/>
+          </a:prstGeom>
+          <a:noFill/>
+          <a:ln/>
+        </p:spPr>
+        <p:txBody>
+          <a:bodyPr wrap="square" lIns="0" tIns="0" rIns="0" bIns="0" rtlCol="0" anchor="ctr"/>
+          <a:lstStyle/>
+          <a:p>
+            <a:pPr marL="0" indent="0">
+              <a:buNone/>
+            </a:pPr>
+            <a:r>
+              <a:rPr lang="en-US" sz="1250" dirty="0">
+                <a:solidFill>
+                  <a:srgbClr val="16181D"/>
                 </a:solidFill>
                 <a:latin typeface="Inter" pitchFamily="34" charset="0"/>
                 <a:ea typeface="Inter" pitchFamily="34" charset="-122"/>
                 <a:cs typeface="Inter" pitchFamily="34" charset="-120"/>
               </a:rPr>
+              <a:t>Month one delivered: Tier-1 automation reached 70.1% in the final week, with faster, better-rated answers.</a:t>
+            </a:r>
+            <a:endParaRPr lang="en-US" sz="1250" dirty="0"/>
+          </a:p>
+        </p:txBody>
+      </p:sp>
+      <p:sp>
+        <p:nvSpPr>
+          <p:cNvPr id="10" name="Shape 7"/>
+          <p:cNvSpPr/>
+          <p:nvPr/>
+        </p:nvSpPr>
+        <p:spPr>
+          <a:xfrm>
+            <a:off x="6812280" y="2236622"/>
+            <a:ext cx="4373575" cy="0"/>
+          </a:xfrm>
+          <a:prstGeom prst="line">
+            <a:avLst/>
+          </a:prstGeom>
+          <a:noFill/>
+          <a:ln w="9525">
+            <a:solidFill>
+              <a:srgbClr val="E6EAF4"/>
+            </a:solidFill>
+            <a:prstDash val="solid"/>
+          </a:ln>
+        </p:spPr>
+      </p:sp>
+      <p:sp>
+        <p:nvSpPr>
+          <p:cNvPr id="11" name="Shape 8"/>
+          <p:cNvSpPr/>
+          <p:nvPr/>
+        </p:nvSpPr>
+        <p:spPr>
+          <a:xfrm>
+            <a:off x="6830568" y="2573122"/>
+            <a:ext cx="118872" cy="118872"/>
+          </a:xfrm>
+          <a:prstGeom prst="rect">
+            <a:avLst/>
+          </a:prstGeom>
+          <a:solidFill>
+            <a:srgbClr val="6720FF"/>
+          </a:solidFill>
+          <a:ln/>
+        </p:spPr>
+      </p:sp>
+      <p:sp>
+        <p:nvSpPr>
+          <p:cNvPr id="12" name="Text 9"/>
+          <p:cNvSpPr txBox="1"/>
+          <p:nvPr/>
+        </p:nvSpPr>
+        <p:spPr>
+          <a:xfrm>
+            <a:off x="7141464" y="2236622"/>
+            <a:ext cx="4044391" cy="791870"/>
+          </a:xfrm>
+          <a:prstGeom prst="rect">
+            <a:avLst/>
+          </a:prstGeom>
+          <a:noFill/>
+          <a:ln/>
+        </p:spPr>
+        <p:txBody>
+          <a:bodyPr wrap="square" lIns="0" tIns="0" rIns="0" bIns="0" rtlCol="0" anchor="ctr"/>
+          <a:lstStyle/>
+          <a:p>
+            <a:pPr marL="0" indent="0">
+              <a:buNone/>
+            </a:pPr>
+            <a:r>
+              <a:rPr lang="en-US" sz="1250" dirty="0">
+                <a:solidFill>
+                  <a:srgbClr val="16181D"/>
+                </a:solidFill>
+                <a:latin typeface="Inter" pitchFamily="34" charset="0"/>
+                <a:ea typeface="Inter" pitchFamily="34" charset="-122"/>
+                <a:cs typeface="Inter" pitchFamily="34" charset="-120"/>
+              </a:rPr>
+              <a:t>Quality improved every week, and the evidence is in your dashboard.</a:t>
+            </a:r>
+            <a:endParaRPr lang="en-US" sz="1250" dirty="0"/>
+          </a:p>
+        </p:txBody>
+      </p:sp>
+      <p:sp>
+        <p:nvSpPr>
+          <p:cNvPr id="13" name="Shape 10"/>
+          <p:cNvSpPr/>
+          <p:nvPr/>
+        </p:nvSpPr>
+        <p:spPr>
+          <a:xfrm>
+            <a:off x="6812280" y="3028493"/>
+            <a:ext cx="4373575" cy="0"/>
+          </a:xfrm>
+          <a:prstGeom prst="line">
+            <a:avLst/>
+          </a:prstGeom>
+          <a:noFill/>
+          <a:ln w="9525">
+            <a:solidFill>
+              <a:srgbClr val="E6EAF4"/>
+            </a:solidFill>
+            <a:prstDash val="solid"/>
+          </a:ln>
+        </p:spPr>
+      </p:sp>
+      <p:sp>
+        <p:nvSpPr>
+          <p:cNvPr id="14" name="Shape 11"/>
+          <p:cNvSpPr/>
+          <p:nvPr/>
+        </p:nvSpPr>
+        <p:spPr>
+          <a:xfrm>
+            <a:off x="6830568" y="3364992"/>
+            <a:ext cx="118872" cy="118872"/>
+          </a:xfrm>
+          <a:prstGeom prst="rect">
+            <a:avLst/>
+          </a:prstGeom>
+          <a:solidFill>
+            <a:srgbClr val="6720FF"/>
+          </a:solidFill>
+          <a:ln/>
+        </p:spPr>
+      </p:sp>
+      <p:sp>
+        <p:nvSpPr>
+          <p:cNvPr id="15" name="Text 12"/>
+          <p:cNvSpPr txBox="1"/>
+          <p:nvPr/>
+        </p:nvSpPr>
+        <p:spPr>
+          <a:xfrm>
+            <a:off x="7141464" y="3028493"/>
+            <a:ext cx="4044391" cy="791870"/>
+          </a:xfrm>
+          <a:prstGeom prst="rect">
+            <a:avLst/>
+          </a:prstGeom>
+          <a:noFill/>
+          <a:ln/>
+        </p:spPr>
+        <p:txBody>
+          <a:bodyPr wrap="square" lIns="0" tIns="0" rIns="0" bIns="0" rtlCol="0" anchor="ctr"/>
+          <a:lstStyle/>
+          <a:p>
+            <a:pPr marL="0" indent="0">
+              <a:buNone/>
+            </a:pPr>
+            <a:r>
+              <a:rPr lang="en-US" sz="1250" dirty="0">
+                <a:solidFill>
+                  <a:srgbClr val="16181D"/>
+                </a:solidFill>
+                <a:latin typeface="Inter" pitchFamily="34" charset="0"/>
+                <a:ea typeface="Inter" pitchFamily="34" charset="-122"/>
+                <a:cs typeface="Inter" pitchFamily="34" charset="-120"/>
+              </a:rPr>
+              <a:t>99.85% availability today: we find the cause in telemetry before buying capacity.</a:t>
+            </a:r>
+            <a:endParaRPr lang="en-US" sz="1250" dirty="0"/>
+          </a:p>
+        </p:txBody>
+      </p:sp>
+      <p:sp>
+        <p:nvSpPr>
+          <p:cNvPr id="16" name="Shape 13"/>
+          <p:cNvSpPr/>
+          <p:nvPr/>
+        </p:nvSpPr>
+        <p:spPr>
+          <a:xfrm>
+            <a:off x="6812280" y="3820363"/>
+            <a:ext cx="4373575" cy="0"/>
+          </a:xfrm>
+          <a:prstGeom prst="line">
+            <a:avLst/>
+          </a:prstGeom>
+          <a:noFill/>
+          <a:ln w="9525">
+            <a:solidFill>
+              <a:srgbClr val="E6EAF4"/>
+            </a:solidFill>
+            <a:prstDash val="solid"/>
+          </a:ln>
+        </p:spPr>
+      </p:sp>
+      <p:sp>
+        <p:nvSpPr>
+          <p:cNvPr id="17" name="Shape 14"/>
+          <p:cNvSpPr/>
+          <p:nvPr/>
+        </p:nvSpPr>
+        <p:spPr>
+          <a:xfrm>
+            <a:off x="6830568" y="4156862"/>
+            <a:ext cx="118872" cy="118872"/>
+          </a:xfrm>
+          <a:prstGeom prst="rect">
+            <a:avLst/>
+          </a:prstGeom>
+          <a:solidFill>
+            <a:srgbClr val="6720FF"/>
+          </a:solidFill>
+          <a:ln/>
+        </p:spPr>
+      </p:sp>
+      <p:sp>
+        <p:nvSpPr>
+          <p:cNvPr id="18" name="Text 15"/>
+          <p:cNvSpPr txBox="1"/>
+          <p:nvPr/>
+        </p:nvSpPr>
+        <p:spPr>
+          <a:xfrm>
+            <a:off x="7141464" y="3820363"/>
+            <a:ext cx="4044391" cy="791870"/>
+          </a:xfrm>
+          <a:prstGeom prst="rect">
+            <a:avLst/>
+          </a:prstGeom>
+          <a:noFill/>
+          <a:ln/>
+        </p:spPr>
+        <p:txBody>
+          <a:bodyPr wrap="square" lIns="0" tIns="0" rIns="0" bIns="0" rtlCol="0" anchor="ctr"/>
+          <a:lstStyle/>
+          <a:p>
+            <a:pPr marL="0" indent="0">
+              <a:buNone/>
+            </a:pPr>
+            <a:r>
+              <a:rPr lang="en-US" sz="1250" dirty="0">
+                <a:solidFill>
+                  <a:srgbClr val="16181D"/>
+                </a:solidFill>
+                <a:latin typeface="Inter" pitchFamily="34" charset="0"/>
+                <a:ea typeface="Inter" pitchFamily="34" charset="-122"/>
+                <a:cs typeface="Inter" pitchFamily="34" charset="-120"/>
+              </a:rPr>
+              <a:t>One base model, one adapter per brand: each brand keeps its voice and its data.</a:t>
+            </a:r>
+            <a:endParaRPr lang="en-US" sz="1250" dirty="0"/>
+          </a:p>
+        </p:txBody>
+      </p:sp>
+      <p:sp>
+        <p:nvSpPr>
+          <p:cNvPr id="19" name="Shape 16"/>
+          <p:cNvSpPr/>
+          <p:nvPr/>
+        </p:nvSpPr>
+        <p:spPr>
+          <a:xfrm>
+            <a:off x="6812280" y="4612234"/>
+            <a:ext cx="4373575" cy="0"/>
+          </a:xfrm>
+          <a:prstGeom prst="line">
+            <a:avLst/>
+          </a:prstGeom>
+          <a:noFill/>
+          <a:ln w="9525">
+            <a:solidFill>
+              <a:srgbClr val="E6EAF4"/>
+            </a:solidFill>
+            <a:prstDash val="solid"/>
+          </a:ln>
+        </p:spPr>
+      </p:sp>
+      <p:sp>
+        <p:nvSpPr>
+          <p:cNvPr id="20" name="Shape 17"/>
+          <p:cNvSpPr/>
+          <p:nvPr/>
+        </p:nvSpPr>
+        <p:spPr>
+          <a:xfrm>
+            <a:off x="6830568" y="4948733"/>
+            <a:ext cx="118872" cy="118872"/>
+          </a:xfrm>
+          <a:prstGeom prst="rect">
+            <a:avLst/>
+          </a:prstGeom>
+          <a:solidFill>
+            <a:srgbClr val="1DA28F"/>
+          </a:solidFill>
+          <a:ln/>
+        </p:spPr>
+      </p:sp>
+      <p:sp>
+        <p:nvSpPr>
+          <p:cNvPr id="21" name="Text 18"/>
+          <p:cNvSpPr txBox="1"/>
+          <p:nvPr/>
+        </p:nvSpPr>
+        <p:spPr>
+          <a:xfrm>
+            <a:off x="7141464" y="4612234"/>
+            <a:ext cx="4044391" cy="791870"/>
+          </a:xfrm>
+          <a:prstGeom prst="rect">
+            <a:avLst/>
+          </a:prstGeom>
+          <a:noFill/>
+          <a:ln/>
+        </p:spPr>
+        <p:txBody>
+          <a:bodyPr wrap="square" lIns="0" tIns="0" rIns="0" bIns="0" rtlCol="0" anchor="ctr"/>
+          <a:lstStyle/>
+          <a:p>
+            <a:pPr marL="0" indent="0">
+              <a:buNone/>
+            </a:pPr>
+            <a:r>
+              <a:rPr lang="en-US" sz="1250" dirty="0">
+                <a:solidFill>
+                  <a:srgbClr val="16181D"/>
+                </a:solidFill>
+                <a:latin typeface="Inter" pitchFamily="34" charset="0"/>
+                <a:ea typeface="Inter" pitchFamily="34" charset="-122"/>
+                <a:cs typeface="Inter" pitchFamily="34" charset="-120"/>
+              </a:rPr>
+              <a:t>We’re asking for a group sponsor today and Ridgeline as the pilot.</a:t>
+            </a:r>
+            <a:endParaRPr lang="en-US" sz="1250" dirty="0"/>
+          </a:p>
+        </p:txBody>
+      </p:sp>
+      <p:sp>
+        <p:nvSpPr>
+          <p:cNvPr id="22" name="Shape 19"/>
+          <p:cNvSpPr/>
+          <p:nvPr/>
+        </p:nvSpPr>
+        <p:spPr>
+          <a:xfrm>
+            <a:off x="731520" y="5760720"/>
+            <a:ext cx="10728655" cy="0"/>
+          </a:xfrm>
+          <a:prstGeom prst="line">
+            <a:avLst/>
+          </a:prstGeom>
+          <a:noFill/>
+          <a:ln w="9525">
+            <a:solidFill>
+              <a:srgbClr val="E6EAF4"/>
+            </a:solidFill>
+            <a:prstDash val="solid"/>
+          </a:ln>
+        </p:spPr>
+      </p:sp>
+      <p:sp>
+        <p:nvSpPr>
+          <p:cNvPr id="23" name="Text 20"/>
+          <p:cNvSpPr txBox="1"/>
+          <p:nvPr/>
+        </p:nvSpPr>
+        <p:spPr>
+          <a:xfrm>
+            <a:off x="731520" y="5925312"/>
+            <a:ext cx="5486400" cy="274320"/>
+          </a:xfrm>
+          <a:prstGeom prst="rect">
+            <a:avLst/>
+          </a:prstGeom>
+          <a:noFill/>
+          <a:ln/>
+        </p:spPr>
+        <p:txBody>
+          <a:bodyPr wrap="square" lIns="0" tIns="0" rIns="0" bIns="0" rtlCol="0" anchor="t"/>
+          <a:lstStyle/>
+          <a:p>
+            <a:pPr marL="0" indent="0">
+              <a:buNone/>
+            </a:pPr>
+            <a:r>
+              <a:rPr lang="en-US" sz="1100" dirty="0">
+                <a:solidFill>
+                  <a:srgbClr val="5A5E63"/>
+                </a:solidFill>
+                <a:latin typeface="Inter" pitchFamily="34" charset="0"/>
+                <a:ea typeface="Inter" pitchFamily="34" charset="-122"/>
+                <a:cs typeface="Inter" pitchFamily="34" charset="-120"/>
+              </a:rPr>
               <a:t>Model ID: </a:t>
             </a:r>
             <a:r>
@@ -4112,7 +4288,7 @@
       </p:sp>
       <p:sp>
         <p:nvSpPr>
-          <p:cNvPr id="23" name="Text 20"/>
+          <p:cNvPr id="24" name="Text 21"/>
           <p:cNvSpPr txBox="1"/>
           <p:nvPr/>
         </p:nvSpPr>
@@ -16356,7 +16532,7 @@
                 <a:ea typeface="Inter Medium" pitchFamily="34" charset="-122"/>
                 <a:cs typeface="Inter Medium" pitchFamily="34" charset="-120"/>
               </a:rPr>
-              <a:t>The rollout must not stall at one brand</a:t>
+              <a:t>Biggest risk: the rollout stalls at one brand</a:t>
             </a:r>
             <a:endParaRPr lang="en-US" sz="2800" dirty="0"/>
           </a:p>
@@ -16399,7 +16575,7 @@
                 <a:ea typeface="Inter" pitchFamily="34" charset="-122"/>
                 <a:cs typeface="Inter" pitchFamily="34" charset="-120"/>
               </a:rPr>
-              <a:t>What we are asking for today.</a:t>
+              <a:t>The risk is commercial and organisational rather than technical: month one worked, but no one owns the rollout above brand level yet.</a:t>
             </a:r>
             <a:endParaRPr lang="en-US" sz="1300" dirty="0"/>
           </a:p>
@@ -16563,7 +16739,7 @@
                 <a:ea typeface="Inter Medium" pitchFamily="34" charset="-122"/>
                 <a:cs typeface="Inter Medium" pitchFamily="34" charset="-120"/>
               </a:rPr>
-              <a:t>Mitigation</a:t>
+              <a:t>Why it matters</a:t>
             </a:r>
             <a:endParaRPr lang="en-US" sz="1050" dirty="0"/>
           </a:p>
@@ -16577,14 +16753,14 @@
         </p:nvSpPr>
         <p:spPr>
           <a:xfrm>
-            <a:off x="1005840" y="4507992"/>
+            <a:off x="1005840" y="4498848"/>
             <a:ext cx="100584" cy="100584"/>
           </a:xfrm>
           <a:prstGeom prst="rect">
             <a:avLst/>
           </a:prstGeom>
           <a:solidFill>
-            <a:srgbClr val="6720FF"/>
+            <a:srgbClr val="F14539"/>
           </a:solidFill>
           <a:ln/>
         </p:spPr>
@@ -16598,7 +16774,7 @@
         <p:spPr>
           <a:xfrm>
             <a:off x="1261872" y="4434840"/>
-            <a:ext cx="4297680" cy="274320"/>
+            <a:ext cx="4297680" cy="457200"/>
           </a:xfrm>
           <a:prstGeom prst="rect">
             <a:avLst/>
@@ -16614,7 +16790,7 @@
               <a:buNone/>
             </a:pPr>
             <a:r>
-              <a:rPr lang="en-US" sz="1200" dirty="0">
+              <a:rPr lang="en-US" sz="1100" dirty="0">
                 <a:solidFill>
                   <a:srgbClr val="28282E"/>
                 </a:solidFill>
@@ -16622,9 +16798,9 @@
                 <a:ea typeface="Inter" pitchFamily="34" charset="-122"/>
                 <a:cs typeface="Inter" pitchFamily="34" charset="-120"/>
               </a:rPr>
-              <a:t>Name a group sponsor at this review</a:t>
-            </a:r>
-            <a:endParaRPr lang="en-US" sz="1200" dirty="0"/>
+              <a:t>Always-on capacity stays a single-brand cost (approx. $5,800/month) rather than $1,200–$1,800 per brand shared.</a:t>
+            </a:r>
+            <a:endParaRPr lang="en-US" sz="1100" dirty="0"/>
           </a:p>
         </p:txBody>
       </p:sp>
@@ -16636,14 +16812,14 @@
         </p:nvSpPr>
         <p:spPr>
           <a:xfrm>
-            <a:off x="1005840" y="4965192"/>
+            <a:off x="1005840" y="5047488"/>
             <a:ext cx="100584" cy="100584"/>
           </a:xfrm>
           <a:prstGeom prst="rect">
             <a:avLst/>
           </a:prstGeom>
           <a:solidFill>
-            <a:srgbClr val="6720FF"/>
+            <a:srgbClr val="F14539"/>
           </a:solidFill>
           <a:ln/>
         </p:spPr>
@@ -16656,8 +16832,8 @@
         </p:nvSpPr>
         <p:spPr>
           <a:xfrm>
-            <a:off x="1261872" y="4892040"/>
-            <a:ext cx="4297680" cy="274320"/>
+            <a:off x="1261872" y="4983480"/>
+            <a:ext cx="4297680" cy="457200"/>
           </a:xfrm>
           <a:prstGeom prst="rect">
             <a:avLst/>
@@ -16673,7 +16849,7 @@
               <a:buNone/>
             </a:pPr>
             <a:r>
-              <a:rPr lang="en-US" sz="1200" dirty="0">
+              <a:rPr lang="en-US" sz="1100" dirty="0">
                 <a:solidFill>
                   <a:srgbClr val="28282E"/>
                 </a:solidFill>
@@ -16681,9 +16857,9 @@
                 <a:ea typeface="Inter" pitchFamily="34" charset="-122"/>
                 <a:cs typeface="Inter" pitchFamily="34" charset="-120"/>
               </a:rPr>
-              <a:t>Agree the Ridgeline pilot criteria together</a:t>
-            </a:r>
-            <a:endParaRPr lang="en-US" sz="1200" dirty="0"/>
+              <a:t>The four sister brands, with most of the group’s Tier-1 volume, don’t get the gains Atlas has shown.</a:t>
+            </a:r>
+            <a:endParaRPr lang="en-US" sz="1100" dirty="0"/>
           </a:p>
         </p:txBody>
       </p:sp>
@@ -16695,14 +16871,14 @@
         </p:nvSpPr>
         <p:spPr>
           <a:xfrm>
-            <a:off x="1005840" y="5422392"/>
+            <a:off x="1005840" y="5596128"/>
             <a:ext cx="100584" cy="100584"/>
           </a:xfrm>
           <a:prstGeom prst="rect">
             <a:avLst/>
           </a:prstGeom>
           <a:solidFill>
-            <a:srgbClr val="6720FF"/>
+            <a:srgbClr val="F14539"/>
           </a:solidFill>
           <a:ln/>
         </p:spPr>
@@ -16715,8 +16891,8 @@
         </p:nvSpPr>
         <p:spPr>
           <a:xfrm>
-            <a:off x="1261872" y="5349240"/>
-            <a:ext cx="4297680" cy="274320"/>
+            <a:off x="1261872" y="5532120"/>
+            <a:ext cx="4297680" cy="457200"/>
           </a:xfrm>
           <a:prstGeom prst="rect">
             <a:avLst/>
@@ -16732,7 +16908,7 @@
               <a:buNone/>
             </a:pPr>
             <a:r>
-              <a:rPr lang="en-US" sz="1200" dirty="0">
+              <a:rPr lang="en-US" sz="1100" dirty="0">
                 <a:solidFill>
                   <a:srgbClr val="28282E"/>
                 </a:solidFill>
@@ -16740,15 +16916,15 @@
                 <a:ea typeface="Inter" pitchFamily="34" charset="-122"/>
                 <a:cs typeface="Inter" pitchFamily="34" charset="-120"/>
               </a:rPr>
-              <a:t>Size shared capacity alongside a second brand</a:t>
-            </a:r>
-            <a:endParaRPr lang="en-US" sz="1200" dirty="0"/>
-          </a:p>
-        </p:txBody>
-      </p:sp>
-      <p:sp>
-        <p:nvSpPr>
-          <p:cNvPr id="16" name="key-messages"/>
+              <a:t>Each brand would make its own platform decision, so the group ends up with several tools to run.</a:t>
+            </a:r>
+            <a:endParaRPr lang="en-US" sz="1100" dirty="0"/>
+          </a:p>
+        </p:txBody>
+      </p:sp>
+      <p:sp>
+        <p:nvSpPr>
+          <p:cNvPr id="16" name="mitigation"/>
           <p:cNvSpPr/>
           <p:nvPr/>
         </p:nvSpPr>
@@ -16806,7 +16982,7 @@
                 <a:ea typeface="Inter Medium" pitchFamily="34" charset="-122"/>
                 <a:cs typeface="Inter Medium" pitchFamily="34" charset="-120"/>
               </a:rPr>
-              <a:t>Key messages</a:t>
+              <a:t>How we mitigate it</a:t>
             </a:r>
             <a:endParaRPr lang="en-US" sz="1050" dirty="0"/>
           </a:p>
@@ -16820,7 +16996,7 @@
         </p:nvSpPr>
         <p:spPr>
           <a:xfrm>
-            <a:off x="6446520" y="2953512"/>
+            <a:off x="6446520" y="2889504"/>
             <a:ext cx="109728" cy="109728"/>
           </a:xfrm>
           <a:prstGeom prst="rect">
@@ -16840,46 +17016,124 @@
         </p:nvSpPr>
         <p:spPr>
           <a:xfrm>
-            <a:off x="6720840" y="2670048"/>
-            <a:ext cx="4465015" cy="676656"/>
-          </a:xfrm>
-          <a:prstGeom prst="rect">
-            <a:avLst/>
-          </a:prstGeom>
-          <a:noFill/>
-          <a:ln/>
-        </p:spPr>
-        <p:txBody>
-          <a:bodyPr wrap="square" lIns="0" tIns="0" rIns="0" bIns="0" rtlCol="0" anchor="ctr"/>
-          <a:lstStyle/>
-          <a:p>
-            <a:pPr marL="0" indent="0">
-              <a:buNone/>
-            </a:pPr>
-            <a:r>
-              <a:rPr lang="en-US" sz="1200" dirty="0">
-                <a:solidFill>
-                  <a:srgbClr val="28282E"/>
+            <a:off x="6720840" y="2816352"/>
+            <a:ext cx="3550615" cy="274320"/>
+          </a:xfrm>
+          <a:prstGeom prst="rect">
+            <a:avLst/>
+          </a:prstGeom>
+          <a:noFill/>
+          <a:ln/>
+        </p:spPr>
+        <p:txBody>
+          <a:bodyPr wrap="square" lIns="0" tIns="0" rIns="0" bIns="0" rtlCol="0" anchor="t"/>
+          <a:lstStyle/>
+          <a:p>
+            <a:pPr marL="0" indent="0">
+              <a:buNone/>
+            </a:pPr>
+            <a:r>
+              <a:rPr lang="en-US" sz="1300" dirty="0">
+                <a:solidFill>
+                  <a:srgbClr val="16181D"/>
+                </a:solidFill>
+                <a:latin typeface="Inter Medium" pitchFamily="34" charset="0"/>
+                <a:ea typeface="Inter Medium" pitchFamily="34" charset="-122"/>
+                <a:cs typeface="Inter Medium" pitchFamily="34" charset="-120"/>
+              </a:rPr>
+              <a:t>Name a group sponsor at this review</a:t>
+            </a:r>
+            <a:endParaRPr lang="en-US" sz="1300" dirty="0"/>
+          </a:p>
+        </p:txBody>
+      </p:sp>
+      <p:sp>
+        <p:nvSpPr>
+          <p:cNvPr id="20" name="Text 18"/>
+          <p:cNvSpPr txBox="1"/>
+          <p:nvPr/>
+        </p:nvSpPr>
+        <p:spPr>
+          <a:xfrm>
+            <a:off x="10271455" y="2816352"/>
+            <a:ext cx="932688" cy="274320"/>
+          </a:xfrm>
+          <a:prstGeom prst="rect">
+            <a:avLst/>
+          </a:prstGeom>
+          <a:noFill/>
+          <a:ln/>
+        </p:spPr>
+        <p:txBody>
+          <a:bodyPr wrap="square" lIns="0" tIns="0" rIns="0" bIns="0" rtlCol="0" anchor="t"/>
+          <a:lstStyle/>
+          <a:p>
+            <a:pPr marL="0" indent="0" algn="r">
+              <a:buNone/>
+            </a:pPr>
+            <a:r>
+              <a:rPr lang="en-US" sz="1100" dirty="0">
+                <a:solidFill>
+                  <a:srgbClr val="501BC4"/>
+                </a:solidFill>
+                <a:latin typeface="Inter Medium" pitchFamily="34" charset="0"/>
+                <a:ea typeface="Inter Medium" pitchFamily="34" charset="-122"/>
+                <a:cs typeface="Inter Medium" pitchFamily="34" charset="-120"/>
+              </a:rPr>
+              <a:t>22 Oct</a:t>
+            </a:r>
+            <a:endParaRPr lang="en-US" sz="1100" dirty="0"/>
+          </a:p>
+        </p:txBody>
+      </p:sp>
+      <p:sp>
+        <p:nvSpPr>
+          <p:cNvPr id="21" name="Text 19"/>
+          <p:cNvSpPr txBox="1"/>
+          <p:nvPr/>
+        </p:nvSpPr>
+        <p:spPr>
+          <a:xfrm>
+            <a:off x="6720840" y="3127248"/>
+            <a:ext cx="4465015" cy="579120"/>
+          </a:xfrm>
+          <a:prstGeom prst="rect">
+            <a:avLst/>
+          </a:prstGeom>
+          <a:noFill/>
+          <a:ln/>
+        </p:spPr>
+        <p:txBody>
+          <a:bodyPr wrap="square" lIns="0" tIns="0" rIns="0" bIns="0" rtlCol="0" anchor="t"/>
+          <a:lstStyle/>
+          <a:p>
+            <a:pPr marL="0" indent="0">
+              <a:buNone/>
+            </a:pPr>
+            <a:r>
+              <a:rPr lang="en-US" sz="1100" dirty="0">
+                <a:solidFill>
+                  <a:srgbClr val="5A5E63"/>
                 </a:solidFill>
                 <a:latin typeface="Inter" pitchFamily="34" charset="0"/>
                 <a:ea typeface="Inter" pitchFamily="34" charset="-122"/>
                 <a:cs typeface="Inter" pitchFamily="34" charset="-120"/>
               </a:rPr>
-              <a:t>Month one delivered: Tier-1 automation reached 70.1% in the final week, with faster, better-rated answers.</a:t>
-            </a:r>
-            <a:endParaRPr lang="en-US" sz="1200" dirty="0"/>
-          </a:p>
-        </p:txBody>
-      </p:sp>
-      <p:sp>
-        <p:nvSpPr>
-          <p:cNvPr id="20" name="Shape 18"/>
-          <p:cNvSpPr/>
-          <p:nvPr/>
-        </p:nvSpPr>
-        <p:spPr>
-          <a:xfrm>
-            <a:off x="6428232" y="3346704"/>
+              <a:t>Someone above brand level who owns the rollout and the wave-2 decision.</a:t>
+            </a:r>
+            <a:endParaRPr lang="en-US" sz="1100" dirty="0"/>
+          </a:p>
+        </p:txBody>
+      </p:sp>
+      <p:sp>
+        <p:nvSpPr>
+          <p:cNvPr id="22" name="Shape 20"/>
+          <p:cNvSpPr/>
+          <p:nvPr/>
+        </p:nvSpPr>
+        <p:spPr>
+          <a:xfrm>
+            <a:off x="6428232" y="3797808"/>
             <a:ext cx="4775911" cy="0"/>
           </a:xfrm>
           <a:prstGeom prst="line">
@@ -16896,13 +17150,13 @@
       </p:sp>
       <p:sp>
         <p:nvSpPr>
-          <p:cNvPr id="21" name="Shape 19"/>
-          <p:cNvSpPr/>
-          <p:nvPr/>
-        </p:nvSpPr>
-        <p:spPr>
-          <a:xfrm>
-            <a:off x="6446520" y="3630168"/>
+          <p:cNvPr id="23" name="Shape 21"/>
+          <p:cNvSpPr/>
+          <p:nvPr/>
+        </p:nvSpPr>
+        <p:spPr>
+          <a:xfrm>
+            <a:off x="6446520" y="4017264"/>
             <a:ext cx="109728" cy="109728"/>
           </a:xfrm>
           <a:prstGeom prst="rect">
@@ -16916,52 +17170,130 @@
       </p:sp>
       <p:sp>
         <p:nvSpPr>
-          <p:cNvPr id="22" name="Text 20"/>
-          <p:cNvSpPr txBox="1"/>
-          <p:nvPr/>
-        </p:nvSpPr>
-        <p:spPr>
-          <a:xfrm>
-            <a:off x="6720840" y="3346704"/>
-            <a:ext cx="4465015" cy="676656"/>
-          </a:xfrm>
-          <a:prstGeom prst="rect">
-            <a:avLst/>
-          </a:prstGeom>
-          <a:noFill/>
-          <a:ln/>
-        </p:spPr>
-        <p:txBody>
-          <a:bodyPr wrap="square" lIns="0" tIns="0" rIns="0" bIns="0" rtlCol="0" anchor="ctr"/>
-          <a:lstStyle/>
-          <a:p>
-            <a:pPr marL="0" indent="0">
-              <a:buNone/>
-            </a:pPr>
-            <a:r>
-              <a:rPr lang="en-US" sz="1200" dirty="0">
-                <a:solidFill>
-                  <a:srgbClr val="28282E"/>
+          <p:cNvPr id="24" name="Text 22"/>
+          <p:cNvSpPr txBox="1"/>
+          <p:nvPr/>
+        </p:nvSpPr>
+        <p:spPr>
+          <a:xfrm>
+            <a:off x="6720840" y="3944112"/>
+            <a:ext cx="3550615" cy="274320"/>
+          </a:xfrm>
+          <a:prstGeom prst="rect">
+            <a:avLst/>
+          </a:prstGeom>
+          <a:noFill/>
+          <a:ln/>
+        </p:spPr>
+        <p:txBody>
+          <a:bodyPr wrap="square" lIns="0" tIns="0" rIns="0" bIns="0" rtlCol="0" anchor="t"/>
+          <a:lstStyle/>
+          <a:p>
+            <a:pPr marL="0" indent="0">
+              <a:buNone/>
+            </a:pPr>
+            <a:r>
+              <a:rPr lang="en-US" sz="1300" dirty="0">
+                <a:solidFill>
+                  <a:srgbClr val="16181D"/>
+                </a:solidFill>
+                <a:latin typeface="Inter Medium" pitchFamily="34" charset="0"/>
+                <a:ea typeface="Inter Medium" pitchFamily="34" charset="-122"/>
+                <a:cs typeface="Inter Medium" pitchFamily="34" charset="-120"/>
+              </a:rPr>
+              <a:t>Agree the Ridgeline pilot criteria together</a:t>
+            </a:r>
+            <a:endParaRPr lang="en-US" sz="1300" dirty="0"/>
+          </a:p>
+        </p:txBody>
+      </p:sp>
+      <p:sp>
+        <p:nvSpPr>
+          <p:cNvPr id="25" name="Text 23"/>
+          <p:cNvSpPr txBox="1"/>
+          <p:nvPr/>
+        </p:nvSpPr>
+        <p:spPr>
+          <a:xfrm>
+            <a:off x="10271455" y="3944112"/>
+            <a:ext cx="932688" cy="274320"/>
+          </a:xfrm>
+          <a:prstGeom prst="rect">
+            <a:avLst/>
+          </a:prstGeom>
+          <a:noFill/>
+          <a:ln/>
+        </p:spPr>
+        <p:txBody>
+          <a:bodyPr wrap="square" lIns="0" tIns="0" rIns="0" bIns="0" rtlCol="0" anchor="t"/>
+          <a:lstStyle/>
+          <a:p>
+            <a:pPr marL="0" indent="0" algn="r">
+              <a:buNone/>
+            </a:pPr>
+            <a:r>
+              <a:rPr lang="en-US" sz="1100" dirty="0">
+                <a:solidFill>
+                  <a:srgbClr val="501BC4"/>
+                </a:solidFill>
+                <a:latin typeface="Inter Medium" pitchFamily="34" charset="0"/>
+                <a:ea typeface="Inter Medium" pitchFamily="34" charset="-122"/>
+                <a:cs typeface="Inter Medium" pitchFamily="34" charset="-120"/>
+              </a:rPr>
+              <a:t>22 Oct</a:t>
+            </a:r>
+            <a:endParaRPr lang="en-US" sz="1100" dirty="0"/>
+          </a:p>
+        </p:txBody>
+      </p:sp>
+      <p:sp>
+        <p:nvSpPr>
+          <p:cNvPr id="26" name="Text 24"/>
+          <p:cNvSpPr txBox="1"/>
+          <p:nvPr/>
+        </p:nvSpPr>
+        <p:spPr>
+          <a:xfrm>
+            <a:off x="6720840" y="4255008"/>
+            <a:ext cx="4465015" cy="579120"/>
+          </a:xfrm>
+          <a:prstGeom prst="rect">
+            <a:avLst/>
+          </a:prstGeom>
+          <a:noFill/>
+          <a:ln/>
+        </p:spPr>
+        <p:txBody>
+          <a:bodyPr wrap="square" lIns="0" tIns="0" rIns="0" bIns="0" rtlCol="0" anchor="t"/>
+          <a:lstStyle/>
+          <a:p>
+            <a:pPr marL="0" indent="0">
+              <a:buNone/>
+            </a:pPr>
+            <a:r>
+              <a:rPr lang="en-US" sz="1100" dirty="0">
+                <a:solidFill>
+                  <a:srgbClr val="5A5E63"/>
                 </a:solidFill>
                 <a:latin typeface="Inter" pitchFamily="34" charset="0"/>
                 <a:ea typeface="Inter" pitchFamily="34" charset="-122"/>
                 <a:cs typeface="Inter" pitchFamily="34" charset="-120"/>
               </a:rPr>
-              <a:t>Quality improved every week, and the evidence is in your dashboard.</a:t>
-            </a:r>
-            <a:endParaRPr lang="en-US" sz="1200" dirty="0"/>
-          </a:p>
-        </p:txBody>
-      </p:sp>
-      <p:sp>
-        <p:nvSpPr>
-          <p:cNvPr id="23" name="Shape 21"/>
-          <p:cNvSpPr/>
-          <p:nvPr/>
-        </p:nvSpPr>
-        <p:spPr>
-          <a:xfrm>
-            <a:off x="6428232" y="4023360"/>
+              <a:t>Success is defined jointly up front, so the readout is a decision rather than a debate.</a:t>
+            </a:r>
+            <a:endParaRPr lang="en-US" sz="1100" dirty="0"/>
+          </a:p>
+        </p:txBody>
+      </p:sp>
+      <p:sp>
+        <p:nvSpPr>
+          <p:cNvPr id="27" name="Shape 25"/>
+          <p:cNvSpPr/>
+          <p:nvPr/>
+        </p:nvSpPr>
+        <p:spPr>
+          <a:xfrm>
+            <a:off x="6428232" y="4925568"/>
             <a:ext cx="4775911" cy="0"/>
           </a:xfrm>
           <a:prstGeom prst="line">
@@ -16978,13 +17310,13 @@
       </p:sp>
       <p:sp>
         <p:nvSpPr>
-          <p:cNvPr id="24" name="Shape 22"/>
-          <p:cNvSpPr/>
-          <p:nvPr/>
-        </p:nvSpPr>
-        <p:spPr>
-          <a:xfrm>
-            <a:off x="6446520" y="4306824"/>
+          <p:cNvPr id="28" name="Shape 26"/>
+          <p:cNvSpPr/>
+          <p:nvPr/>
+        </p:nvSpPr>
+        <p:spPr>
+          <a:xfrm>
+            <a:off x="6446520" y="5145024"/>
             <a:ext cx="109728" cy="109728"/>
           </a:xfrm>
           <a:prstGeom prst="rect">
@@ -16998,204 +17330,118 @@
       </p:sp>
       <p:sp>
         <p:nvSpPr>
-          <p:cNvPr id="25" name="Text 23"/>
-          <p:cNvSpPr txBox="1"/>
-          <p:nvPr/>
-        </p:nvSpPr>
-        <p:spPr>
-          <a:xfrm>
-            <a:off x="6720840" y="4023360"/>
-            <a:ext cx="4465015" cy="676656"/>
-          </a:xfrm>
-          <a:prstGeom prst="rect">
-            <a:avLst/>
-          </a:prstGeom>
-          <a:noFill/>
-          <a:ln/>
-        </p:spPr>
-        <p:txBody>
-          <a:bodyPr wrap="square" lIns="0" tIns="0" rIns="0" bIns="0" rtlCol="0" anchor="ctr"/>
-          <a:lstStyle/>
-          <a:p>
-            <a:pPr marL="0" indent="0">
-              <a:buNone/>
-            </a:pPr>
-            <a:r>
-              <a:rPr lang="en-US" sz="1200" dirty="0">
-                <a:solidFill>
-                  <a:srgbClr val="28282E"/>
+          <p:cNvPr id="29" name="Text 27"/>
+          <p:cNvSpPr txBox="1"/>
+          <p:nvPr/>
+        </p:nvSpPr>
+        <p:spPr>
+          <a:xfrm>
+            <a:off x="6720840" y="5071872"/>
+            <a:ext cx="3550615" cy="274320"/>
+          </a:xfrm>
+          <a:prstGeom prst="rect">
+            <a:avLst/>
+          </a:prstGeom>
+          <a:noFill/>
+          <a:ln/>
+        </p:spPr>
+        <p:txBody>
+          <a:bodyPr wrap="square" lIns="0" tIns="0" rIns="0" bIns="0" rtlCol="0" anchor="t"/>
+          <a:lstStyle/>
+          <a:p>
+            <a:pPr marL="0" indent="0">
+              <a:buNone/>
+            </a:pPr>
+            <a:r>
+              <a:rPr lang="en-US" sz="1300" dirty="0">
+                <a:solidFill>
+                  <a:srgbClr val="16181D"/>
+                </a:solidFill>
+                <a:latin typeface="Inter Medium" pitchFamily="34" charset="0"/>
+                <a:ea typeface="Inter Medium" pitchFamily="34" charset="-122"/>
+                <a:cs typeface="Inter Medium" pitchFamily="34" charset="-120"/>
+              </a:rPr>
+              <a:t>Size shared capacity with a second brand</a:t>
+            </a:r>
+            <a:endParaRPr lang="en-US" sz="1300" dirty="0"/>
+          </a:p>
+        </p:txBody>
+      </p:sp>
+      <p:sp>
+        <p:nvSpPr>
+          <p:cNvPr id="30" name="Text 28"/>
+          <p:cNvSpPr txBox="1"/>
+          <p:nvPr/>
+        </p:nvSpPr>
+        <p:spPr>
+          <a:xfrm>
+            <a:off x="10271455" y="5071872"/>
+            <a:ext cx="932688" cy="274320"/>
+          </a:xfrm>
+          <a:prstGeom prst="rect">
+            <a:avLst/>
+          </a:prstGeom>
+          <a:noFill/>
+          <a:ln/>
+        </p:spPr>
+        <p:txBody>
+          <a:bodyPr wrap="square" lIns="0" tIns="0" rIns="0" bIns="0" rtlCol="0" anchor="t"/>
+          <a:lstStyle/>
+          <a:p>
+            <a:pPr marL="0" indent="0" algn="r">
+              <a:buNone/>
+            </a:pPr>
+            <a:r>
+              <a:rPr lang="en-US" sz="1100" dirty="0">
+                <a:solidFill>
+                  <a:srgbClr val="501BC4"/>
+                </a:solidFill>
+                <a:latin typeface="Inter Medium" pitchFamily="34" charset="0"/>
+                <a:ea typeface="Inter Medium" pitchFamily="34" charset="-122"/>
+                <a:cs typeface="Inter Medium" pitchFamily="34" charset="-120"/>
+              </a:rPr>
+              <a:t>Nov 2026</a:t>
+            </a:r>
+            <a:endParaRPr lang="en-US" sz="1100" dirty="0"/>
+          </a:p>
+        </p:txBody>
+      </p:sp>
+      <p:sp>
+        <p:nvSpPr>
+          <p:cNvPr id="31" name="Text 29"/>
+          <p:cNvSpPr txBox="1"/>
+          <p:nvPr/>
+        </p:nvSpPr>
+        <p:spPr>
+          <a:xfrm>
+            <a:off x="6720840" y="5382768"/>
+            <a:ext cx="4465015" cy="579120"/>
+          </a:xfrm>
+          <a:prstGeom prst="rect">
+            <a:avLst/>
+          </a:prstGeom>
+          <a:noFill/>
+          <a:ln/>
+        </p:spPr>
+        <p:txBody>
+          <a:bodyPr wrap="square" lIns="0" tIns="0" rIns="0" bIns="0" rtlCol="0" anchor="t"/>
+          <a:lstStyle/>
+          <a:p>
+            <a:pPr marL="0" indent="0">
+              <a:buNone/>
+            </a:pPr>
+            <a:r>
+              <a:rPr lang="en-US" sz="1100" dirty="0">
+                <a:solidFill>
+                  <a:srgbClr val="5A5E63"/>
                 </a:solidFill>
                 <a:latin typeface="Inter" pitchFamily="34" charset="0"/>
                 <a:ea typeface="Inter" pitchFamily="34" charset="-122"/>
                 <a:cs typeface="Inter" pitchFamily="34" charset="-120"/>
               </a:rPr>
-              <a:t>99.85% today: we find the cause in telemetry before buying capacity.</a:t>
-            </a:r>
-            <a:endParaRPr lang="en-US" sz="1200" dirty="0"/>
-          </a:p>
-        </p:txBody>
-      </p:sp>
-      <p:sp>
-        <p:nvSpPr>
-          <p:cNvPr id="26" name="Shape 24"/>
-          <p:cNvSpPr/>
-          <p:nvPr/>
-        </p:nvSpPr>
-        <p:spPr>
-          <a:xfrm>
-            <a:off x="6428232" y="4700016"/>
-            <a:ext cx="4775911" cy="0"/>
-          </a:xfrm>
-          <a:prstGeom prst="line">
-            <a:avLst/>
-          </a:prstGeom>
-          <a:noFill/>
-          <a:ln w="9525">
-            <a:solidFill>
-              <a:srgbClr val="E6EAF4"/>
-            </a:solidFill>
-            <a:prstDash val="solid"/>
-          </a:ln>
-        </p:spPr>
-      </p:sp>
-      <p:sp>
-        <p:nvSpPr>
-          <p:cNvPr id="27" name="Shape 25"/>
-          <p:cNvSpPr/>
-          <p:nvPr/>
-        </p:nvSpPr>
-        <p:spPr>
-          <a:xfrm>
-            <a:off x="6446520" y="4983480"/>
-            <a:ext cx="109728" cy="109728"/>
-          </a:xfrm>
-          <a:prstGeom prst="rect">
-            <a:avLst/>
-          </a:prstGeom>
-          <a:solidFill>
-            <a:srgbClr val="6720FF"/>
-          </a:solidFill>
-          <a:ln/>
-        </p:spPr>
-      </p:sp>
-      <p:sp>
-        <p:nvSpPr>
-          <p:cNvPr id="28" name="Text 26"/>
-          <p:cNvSpPr txBox="1"/>
-          <p:nvPr/>
-        </p:nvSpPr>
-        <p:spPr>
-          <a:xfrm>
-            <a:off x="6720840" y="4700016"/>
-            <a:ext cx="4465015" cy="676656"/>
-          </a:xfrm>
-          <a:prstGeom prst="rect">
-            <a:avLst/>
-          </a:prstGeom>
-          <a:noFill/>
-          <a:ln/>
-        </p:spPr>
-        <p:txBody>
-          <a:bodyPr wrap="square" lIns="0" tIns="0" rIns="0" bIns="0" rtlCol="0" anchor="ctr"/>
-          <a:lstStyle/>
-          <a:p>
-            <a:pPr marL="0" indent="0">
-              <a:buNone/>
-            </a:pPr>
-            <a:r>
-              <a:rPr lang="en-US" sz="1200" dirty="0">
-                <a:solidFill>
-                  <a:srgbClr val="28282E"/>
-                </a:solidFill>
-                <a:latin typeface="Inter" pitchFamily="34" charset="0"/>
-                <a:ea typeface="Inter" pitchFamily="34" charset="-122"/>
-                <a:cs typeface="Inter" pitchFamily="34" charset="-120"/>
-              </a:rPr>
-              <a:t>One base, one adapter per brand: each brand keeps its voice and its data.</a:t>
-            </a:r>
-            <a:endParaRPr lang="en-US" sz="1200" dirty="0"/>
-          </a:p>
-        </p:txBody>
-      </p:sp>
-      <p:sp>
-        <p:nvSpPr>
-          <p:cNvPr id="29" name="Shape 27"/>
-          <p:cNvSpPr/>
-          <p:nvPr/>
-        </p:nvSpPr>
-        <p:spPr>
-          <a:xfrm>
-            <a:off x="6428232" y="5376672"/>
-            <a:ext cx="4775911" cy="0"/>
-          </a:xfrm>
-          <a:prstGeom prst="line">
-            <a:avLst/>
-          </a:prstGeom>
-          <a:noFill/>
-          <a:ln w="9525">
-            <a:solidFill>
-              <a:srgbClr val="E6EAF4"/>
-            </a:solidFill>
-            <a:prstDash val="solid"/>
-          </a:ln>
-        </p:spPr>
-      </p:sp>
-      <p:sp>
-        <p:nvSpPr>
-          <p:cNvPr id="30" name="Shape 28"/>
-          <p:cNvSpPr/>
-          <p:nvPr/>
-        </p:nvSpPr>
-        <p:spPr>
-          <a:xfrm>
-            <a:off x="6446520" y="5660136"/>
-            <a:ext cx="109728" cy="109728"/>
-          </a:xfrm>
-          <a:prstGeom prst="rect">
-            <a:avLst/>
-          </a:prstGeom>
-          <a:solidFill>
-            <a:srgbClr val="1DA28F"/>
-          </a:solidFill>
-          <a:ln/>
-        </p:spPr>
-      </p:sp>
-      <p:sp>
-        <p:nvSpPr>
-          <p:cNvPr id="31" name="Text 29"/>
-          <p:cNvSpPr txBox="1"/>
-          <p:nvPr/>
-        </p:nvSpPr>
-        <p:spPr>
-          <a:xfrm>
-            <a:off x="6720840" y="5376672"/>
-            <a:ext cx="4465015" cy="676656"/>
-          </a:xfrm>
-          <a:prstGeom prst="rect">
-            <a:avLst/>
-          </a:prstGeom>
-          <a:noFill/>
-          <a:ln/>
-        </p:spPr>
-        <p:txBody>
-          <a:bodyPr wrap="square" lIns="0" tIns="0" rIns="0" bIns="0" rtlCol="0" anchor="ctr"/>
-          <a:lstStyle/>
-          <a:p>
-            <a:pPr marL="0" indent="0">
-              <a:buNone/>
-            </a:pPr>
-            <a:r>
-              <a:rPr lang="en-US" sz="1200" dirty="0">
-                <a:solidFill>
-                  <a:srgbClr val="28282E"/>
-                </a:solidFill>
-                <a:latin typeface="Inter" pitchFamily="34" charset="0"/>
-                <a:ea typeface="Inter" pitchFamily="34" charset="-122"/>
-                <a:cs typeface="Inter" pitchFamily="34" charset="-120"/>
-              </a:rPr>
-              <a:t>We’re asking for a group sponsor today and Ridgeline as the pilot.</a:t>
-            </a:r>
-            <a:endParaRPr lang="en-US" sz="1200" dirty="0"/>
+              <a:t>Capacity is committed with Ridgeline from a load benchmark, never for Atlas alone.</a:t>
+            </a:r>
+            <a:endParaRPr lang="en-US" sz="1100" dirty="0"/>
           </a:p>
         </p:txBody>
       </p:sp>

</xml_diff>